<commit_message>
Add light & shadow module; fix stray paragraph properties in existing decks
Co-Authored-By: Claude Opus 5.5 <noreply@anthropic.com>
Claude-Session: https://claude.ai/code/session_01KKvXVKdxZpAmQSV8JauqKv
</commit_message>
<xml_diff>
--- a/SOCIAL_MEDIA_PREZENTARE.pptx
+++ b/SOCIAL_MEDIA_PREZENTARE.pptx
@@ -7517,9 +7517,6 @@
               </a:rPr>
               <a:t>România: </a:t>
             </a:r>
-            <a:pPr indent="0" marL="0">
-              <a:buNone/>
-            </a:pPr>
             <a:r>
               <a:rPr lang="en-US" sz="1200" dirty="0">
                 <a:solidFill>
@@ -7851,9 +7848,6 @@
               </a:rPr>
               <a:t>Verifici: </a:t>
             </a:r>
-            <a:pPr indent="0" marL="0">
-              <a:buNone/>
-            </a:pPr>
             <a:r>
               <a:rPr lang="en-US" sz="1200" dirty="0">
                 <a:solidFill>
@@ -16991,9 +16985,6 @@
               </a:rPr>
               <a:t>Identitate vizuală: </a:t>
             </a:r>
-            <a:pPr indent="0" marL="0">
-              <a:buNone/>
-            </a:pPr>
             <a:r>
               <a:rPr lang="en-US" sz="1300" dirty="0">
                 <a:solidFill>
@@ -18730,9 +18721,6 @@
               </a:rPr>
               <a:t>Anti-emoții: </a:t>
             </a:r>
-            <a:pPr indent="0" marL="0">
-              <a:buNone/>
-            </a:pPr>
             <a:r>
               <a:rPr lang="en-US" sz="1300" dirty="0">
                 <a:solidFill>
@@ -19285,9 +19273,6 @@
               </a:rPr>
               <a:t>Creezi: </a:t>
             </a:r>
-            <a:pPr indent="0" marL="0">
-              <a:buNone/>
-            </a:pPr>
             <a:r>
               <a:rPr lang="en-US" sz="1300" dirty="0">
                 <a:solidFill>

</xml_diff>